<commit_message>
M1: fix overstated 'reuse prompt in next module' claim, add concrete exercise scenario (HTML, PPT, PDF)
</commit_message>
<xml_diff>
--- a/K2-Produktivitas/M01-Role-Prompting/K2-M01-Role-Prompting.pptx
+++ b/K2-Produktivitas/M01-Role-Prompting/K2-M01-Role-Prompting.pptx
@@ -3063,11 +3063,11 @@
         <p:spPr>
           <a:xfrm>
             <a:off x="548640" y="2011680"/>
-            <a:ext cx="3527450" cy="1481145"/>
+            <a:ext cx="3527450" cy="1919935"/>
           </a:xfrm>
           <a:prstGeom prst="roundRect">
             <a:avLst>
-              <a:gd name="adj" fmla="val 6174"/>
+              <a:gd name="adj" fmla="val 4763"/>
             </a:avLst>
           </a:prstGeom>
           <a:solidFill>
@@ -3188,7 +3188,7 @@
         <p:spPr>
           <a:xfrm>
             <a:off x="749808" y="2633472"/>
-            <a:ext cx="3125114" cy="658185"/>
+            <a:ext cx="3125114" cy="1096975"/>
           </a:xfrm>
           <a:prstGeom prst="rect">
             <a:avLst/>
@@ -3215,7 +3215,7 @@
                 <a:ea typeface="Helvetica" pitchFamily="34" charset="-122"/>
                 <a:cs typeface="Helvetica" pitchFamily="34" charset="-120"/>
               </a:rPr>
-              <a:t>Pilih satu email, dokumen, atau pesan yang perlu kamu buat minggu ini — sesuatu yang benar-benar ada di to-do list kamu.</a:t>
+              <a:t>Pilih satu email, dokumen, atau pesan yang perlu kamu buat minggu ini. Belum ada yang mendesak? Coba skenario: DM Instagram tanya ukuran &amp; warna baju yang gak gampang kotor.</a:t>
             </a:r>
             <a:endParaRPr lang="en-US" sz="1200" dirty="0"/>
           </a:p>
@@ -3230,11 +3230,11 @@
         <p:spPr>
           <a:xfrm>
             <a:off x="4332122" y="2011680"/>
-            <a:ext cx="3527450" cy="1481145"/>
+            <a:ext cx="3527450" cy="1919935"/>
           </a:xfrm>
           <a:prstGeom prst="roundRect">
             <a:avLst>
-              <a:gd name="adj" fmla="val 6174"/>
+              <a:gd name="adj" fmla="val 4763"/>
             </a:avLst>
           </a:prstGeom>
           <a:solidFill>
@@ -3355,7 +3355,7 @@
         <p:spPr>
           <a:xfrm>
             <a:off x="4533290" y="2633472"/>
-            <a:ext cx="3125114" cy="658185"/>
+            <a:ext cx="3125114" cy="1096975"/>
           </a:xfrm>
           <a:prstGeom prst="rect">
             <a:avLst/>
@@ -3397,11 +3397,11 @@
         <p:spPr>
           <a:xfrm>
             <a:off x="8115605" y="2011680"/>
-            <a:ext cx="3527450" cy="1481145"/>
+            <a:ext cx="3527450" cy="1919935"/>
           </a:xfrm>
           <a:prstGeom prst="roundRect">
             <a:avLst>
-              <a:gd name="adj" fmla="val 6174"/>
+              <a:gd name="adj" fmla="val 4763"/>
             </a:avLst>
           </a:prstGeom>
           <a:solidFill>
@@ -3522,7 +3522,7 @@
         <p:spPr>
           <a:xfrm>
             <a:off x="8316773" y="2633472"/>
-            <a:ext cx="3125114" cy="658185"/>
+            <a:ext cx="3125114" cy="1096975"/>
           </a:xfrm>
           <a:prstGeom prst="rect">
             <a:avLst/>
@@ -3563,7 +3563,7 @@
         </p:nvSpPr>
         <p:spPr>
           <a:xfrm>
-            <a:off x="548640" y="3730569"/>
+            <a:off x="548640" y="4169359"/>
             <a:ext cx="11094415" cy="993331"/>
           </a:xfrm>
           <a:prstGeom prst="roundRect">
@@ -3590,7 +3590,7 @@
         </p:nvSpPr>
         <p:spPr>
           <a:xfrm>
-            <a:off x="749808" y="3931737"/>
+            <a:off x="749808" y="4370527"/>
             <a:ext cx="10692079" cy="274320"/>
           </a:xfrm>
           <a:prstGeom prst="rect">
@@ -3629,7 +3629,7 @@
         </p:nvSpPr>
         <p:spPr>
           <a:xfrm>
-            <a:off x="749808" y="4279209"/>
+            <a:off x="749808" y="4717999"/>
             <a:ext cx="10692079" cy="243523"/>
           </a:xfrm>
           <a:prstGeom prst="rect">
@@ -3657,7 +3657,7 @@
                 <a:ea typeface="Helvetica" pitchFamily="34" charset="-122"/>
                 <a:cs typeface="Helvetica" pitchFamily="34" charset="-120"/>
               </a:rPr>
-              <a:t>1 draft siap pakai dari 4-elemen prompt. Simpan promptnya — kamu akan pakai lagi di modul berikutnya.</a:t>
+              <a:t>1 draft siap pakai dari 4-elemen prompt. Framework-nya (bukan prompt yang sama persis) yang akan kamu pakai lagi di modul berikutnya.</a:t>
             </a:r>
             <a:endParaRPr lang="en-US" sz="1250" dirty="0"/>
           </a:p>

</xml_diff>

<commit_message>
M1: fold scenario into exercise box, simplify output to describe actual deliverable
</commit_message>
<xml_diff>
--- a/K2-Produktivitas/M01-Role-Prompting/K2-M01-Role-Prompting.pptx
+++ b/K2-Produktivitas/M01-Role-Prompting/K2-M01-Role-Prompting.pptx
@@ -3063,11 +3063,11 @@
         <p:spPr>
           <a:xfrm>
             <a:off x="548640" y="2011680"/>
-            <a:ext cx="3527450" cy="1919935"/>
+            <a:ext cx="3527450" cy="1700540"/>
           </a:xfrm>
           <a:prstGeom prst="roundRect">
             <a:avLst>
-              <a:gd name="adj" fmla="val 4763"/>
+              <a:gd name="adj" fmla="val 5377"/>
             </a:avLst>
           </a:prstGeom>
           <a:solidFill>
@@ -3173,7 +3173,7 @@
                 <a:ea typeface="Helvetica" pitchFamily="34" charset="-122"/>
                 <a:cs typeface="Helvetica" pitchFamily="34" charset="-120"/>
               </a:rPr>
-              <a:t>Pilih 1 task nyata</a:t>
+              <a:t>Pilih skenario atau task nyata</a:t>
             </a:r>
             <a:endParaRPr lang="en-US" sz="1400" dirty="0"/>
           </a:p>
@@ -3188,7 +3188,7 @@
         <p:spPr>
           <a:xfrm>
             <a:off x="749808" y="2633472"/>
-            <a:ext cx="3125114" cy="1096975"/>
+            <a:ext cx="3125114" cy="877580"/>
           </a:xfrm>
           <a:prstGeom prst="rect">
             <a:avLst/>
@@ -3215,7 +3215,7 @@
                 <a:ea typeface="Helvetica" pitchFamily="34" charset="-122"/>
                 <a:cs typeface="Helvetica" pitchFamily="34" charset="-120"/>
               </a:rPr>
-              <a:t>Pilih satu email, dokumen, atau pesan yang perlu kamu buat minggu ini. Belum ada yang mendesak? Coba skenario: DM Instagram tanya ukuran &amp; warna baju yang gak gampang kotor.</a:t>
+              <a:t>Contoh: DM Instagram — “Badan aku agak berisi, kemeja linen size M muat gak ya? Warna apa yang gak gampang kotor?” Atau pakai email/dokumen nyata dari minggu ini.</a:t>
             </a:r>
             <a:endParaRPr lang="en-US" sz="1200" dirty="0"/>
           </a:p>
@@ -3230,11 +3230,11 @@
         <p:spPr>
           <a:xfrm>
             <a:off x="4332122" y="2011680"/>
-            <a:ext cx="3527450" cy="1919935"/>
+            <a:ext cx="3527450" cy="1700540"/>
           </a:xfrm>
           <a:prstGeom prst="roundRect">
             <a:avLst>
-              <a:gd name="adj" fmla="val 4763"/>
+              <a:gd name="adj" fmla="val 5377"/>
             </a:avLst>
           </a:prstGeom>
           <a:solidFill>
@@ -3355,7 +3355,7 @@
         <p:spPr>
           <a:xfrm>
             <a:off x="4533290" y="2633472"/>
-            <a:ext cx="3125114" cy="1096975"/>
+            <a:ext cx="3125114" cy="877580"/>
           </a:xfrm>
           <a:prstGeom prst="rect">
             <a:avLst/>
@@ -3397,11 +3397,11 @@
         <p:spPr>
           <a:xfrm>
             <a:off x="8115605" y="2011680"/>
-            <a:ext cx="3527450" cy="1919935"/>
+            <a:ext cx="3527450" cy="1700540"/>
           </a:xfrm>
           <a:prstGeom prst="roundRect">
             <a:avLst>
-              <a:gd name="adj" fmla="val 4763"/>
+              <a:gd name="adj" fmla="val 5377"/>
             </a:avLst>
           </a:prstGeom>
           <a:solidFill>
@@ -3522,7 +3522,7 @@
         <p:spPr>
           <a:xfrm>
             <a:off x="8316773" y="2633472"/>
-            <a:ext cx="3125114" cy="1096975"/>
+            <a:ext cx="3125114" cy="877580"/>
           </a:xfrm>
           <a:prstGeom prst="rect">
             <a:avLst/>
@@ -3563,12 +3563,12 @@
         </p:nvSpPr>
         <p:spPr>
           <a:xfrm>
-            <a:off x="548640" y="4169359"/>
-            <a:ext cx="11094415" cy="993331"/>
+            <a:off x="548640" y="3949964"/>
+            <a:ext cx="11094415" cy="1236853"/>
           </a:xfrm>
           <a:prstGeom prst="roundRect">
             <a:avLst>
-              <a:gd name="adj" fmla="val 9205"/>
+              <a:gd name="adj" fmla="val 7393"/>
             </a:avLst>
           </a:prstGeom>
           <a:solidFill>
@@ -3590,7 +3590,7 @@
         </p:nvSpPr>
         <p:spPr>
           <a:xfrm>
-            <a:off x="749808" y="4370527"/>
+            <a:off x="749808" y="4151132"/>
             <a:ext cx="10692079" cy="274320"/>
           </a:xfrm>
           <a:prstGeom prst="rect">
@@ -3629,8 +3629,8 @@
         </p:nvSpPr>
         <p:spPr>
           <a:xfrm>
-            <a:off x="749808" y="4717999"/>
-            <a:ext cx="10692079" cy="243523"/>
+            <a:off x="749808" y="4498604"/>
+            <a:ext cx="10692079" cy="487045"/>
           </a:xfrm>
           <a:prstGeom prst="rect">
             <a:avLst/>
@@ -3657,7 +3657,7 @@
                 <a:ea typeface="Helvetica" pitchFamily="34" charset="-122"/>
                 <a:cs typeface="Helvetica" pitchFamily="34" charset="-120"/>
               </a:rPr>
-              <a:t>1 draft siap pakai dari 4-elemen prompt. Framework-nya (bukan prompt yang sama persis) yang akan kamu pakai lagi di modul berikutnya.</a:t>
+              <a:t>1 draft pesan siap kirim — kalau pakai skenario di atas, artinya 1 balasan DM Instagram yang menjawab pertanyaan pelanggan dan mengarahkan ke pembelian, tanpa perlu diedit ulang.</a:t>
             </a:r>
             <a:endParaRPr lang="en-US" sz="1250" dirty="0"/>
           </a:p>

</xml_diff>